<commit_message>
docs: update README and pitch deck with hybrid model results
Top-1 61.5% (was 38.5% for the retrained EfficientNet-B0), top-3 100%,
81.3% accuracy on trusted photos, peak selective accuracy 85% at trust >= 0.61.

Co-Authored-By: Claude Sonnet 5.5 <noreply@anthropic.com>
</commit_message>
<xml_diff>
--- a/PlantDoc_Pitch_Deck.pptx
+++ b/PlantDoc_Pitch_Deck.pptx
@@ -3766,7 +3766,7 @@
               </a:defRPr>
             </a:pPr>
             <a:r>
-              <a:t>2. Transfer Classifier</a:t>
+              <a:t>2. Hybrid Classifier</a:t>
             </a:r>
           </a:p>
           <a:p>
@@ -3781,7 +3781,7 @@
               </a:defRPr>
             </a:pPr>
             <a:r>
-              <a:t>• Backbone: EfficientNet-B0 (timm), chosen for ultra-fast mobile CPU inference.</a:t>
+              <a:t>• CLAHE on the LAB L-channel normalises uneven field lighting.</a:t>
             </a:r>
           </a:p>
           <a:p>
@@ -3796,7 +3796,7 @@
               </a:defRPr>
             </a:pPr>
             <a:r>
-              <a:t>• Pretrained on ImageNet, fine-tuned on PlantDoc field photos.</a:t>
+              <a:t>• Fuses frozen Swin-T + DINOv2 ViT-B + ConvNeXt-T features (CNN + Transformer).</a:t>
             </a:r>
           </a:p>
           <a:p>
@@ -3811,7 +3811,7 @@
               </a:defRPr>
             </a:pPr>
             <a:r>
-              <a:t>• Heavy domain augmentations: Random affine, color jitter, multi-angle flips.</a:t>
+              <a:t>• Chosen from 6 backbones and 10 hybrids by 5-fold CV: 62.7% vs 50.1% for EfficientNet-B0.</a:t>
             </a:r>
           </a:p>
           <a:p>
@@ -3826,7 +3826,7 @@
               </a:defRPr>
             </a:pPr>
             <a:r>
-              <a:t>• Class-weighted loss function handles real-world class imbalances.</a:t>
+              <a:t>• Class-balanced linear head; temperature-calibrated confidence (0.37 s on CPU).</a:t>
             </a:r>
           </a:p>
         </p:txBody>
@@ -4080,7 +4080,7 @@
               </a:defRPr>
             </a:pPr>
             <a:r>
-              <a:t>• Computes gradients on final conv layer (conv_head).</a:t>
+              <a:t>• Computes gradients on the ConvNeXt branch of the hybrid.</a:t>
             </a:r>
           </a:p>
           <a:p>
@@ -4466,7 +4466,7 @@
               </a:defRPr>
             </a:pPr>
             <a:r>
-              <a:t>• Top-1 Accuracy: 50.00% | Top-3 Accuracy: 76.92% on difficult field photos.</a:t>
+              <a:t>• Top-1 Accuracy: 61.54% | Top-3 Accuracy: 100% (EfficientNet-B0: 38.5% | 80.8%).</a:t>
             </a:r>
           </a:p>
           <a:p>
@@ -4496,7 +4496,7 @@
               </a:defRPr>
             </a:pPr>
             <a:r>
-              <a:t>• Diagnostic Accuracy on TRUSTED photos jumps to 60.00% (peaks at 71.4%).</a:t>
+              <a:t>• Diagnostic Accuracy on TRUSTED photos jumps to 81.25% (peaks at 85.0%).</a:t>
             </a:r>
           </a:p>
           <a:p>
@@ -4598,7 +4598,7 @@
               </a:defRPr>
             </a:pPr>
             <a:r>
-              <a:t>• Key Finding: Filtering unconfident/poor images yields a +10% to +21.4% precision boost.</a:t>
+              <a:t>• Key Finding: Filtering unconfident/poor images yields a +19.7 to +23.5 point precision boost.</a:t>
             </a:r>
           </a:p>
           <a:p>

</xml_diff>

<commit_message>
docs: update README, dev log, pitch deck, and presentation materials
</commit_message>
<xml_diff>
--- a/PlantDoc_Pitch_Deck.pptx
+++ b/PlantDoc_Pitch_Deck.pptx
@@ -12,6 +12,7 @@
     <p:sldId id="260" r:id="rId11"/>
     <p:sldId id="261" r:id="rId12"/>
     <p:sldId id="262" r:id="rId13"/>
+    <p:sldId id="263" r:id="rId14"/>
   </p:sldIdLst>
   <p:sldSz cx="12191695" cy="6858000" type="screen4x3"/>
   <p:notesSz cx="6858000" cy="9144000"/>
@@ -3664,7 +3665,7 @@
               </a:defRPr>
             </a:pPr>
             <a:r>
-              <a:t>• Blur Detection: Variance of Laplacian catches shaky smartphone captures.</a:t>
+              <a:t>• Blur: Laplacian variance + directional gradients catch defocus and motion blur.</a:t>
             </a:r>
           </a:p>
           <a:p>
@@ -3694,7 +3695,7 @@
               </a:defRPr>
             </a:pPr>
             <a:r>
-              <a:t>• Leaf Coverage: Dual HSV green + lesion masks ensure leaf fills the frame.</a:t>
+              <a:t>• Leaf Coverage: green tissue + adjacent lesions; bare soil is not counted as leaf.</a:t>
             </a:r>
           </a:p>
           <a:p>
@@ -3796,37 +3797,37 @@
               </a:defRPr>
             </a:pPr>
             <a:r>
-              <a:t>• Fuses frozen Swin-T + DINOv2 ViT-B + ConvNeXt-T features (CNN + Transformer).</a:t>
-            </a:r>
-          </a:p>
-          <a:p>
-            <a:pPr>
-              <a:spcAft>
-                <a:spcPts val="600"/>
-              </a:spcAft>
-              <a:defRPr sz="1300">
-                <a:solidFill>
-                  <a:srgbClr val="2C3E50"/>
-                </a:solidFill>
-              </a:defRPr>
-            </a:pPr>
-            <a:r>
-              <a:t>• Chosen from 6 backbones and 10 hybrids by 5-fold CV: 62.7% vs 50.1% for EfficientNet-B0.</a:t>
-            </a:r>
-          </a:p>
-          <a:p>
-            <a:pPr>
-              <a:spcAft>
-                <a:spcPts val="600"/>
-              </a:spcAft>
-              <a:defRPr sz="1300">
-                <a:solidFill>
-                  <a:srgbClr val="2C3E50"/>
-                </a:solidFill>
-              </a:defRPr>
-            </a:pPr>
-            <a:r>
-              <a:t>• Class-balanced linear head; temperature-calibrated confidence (0.37 s on CPU).</a:t>
+              <a:t>• Fuses frozen ConvNeXt-T (CNN) + DINOv2 ViT-S (Transformer) features.</a:t>
+            </a:r>
+          </a:p>
+          <a:p>
+            <a:pPr>
+              <a:spcAft>
+                <a:spcPts val="600"/>
+              </a:spcAft>
+              <a:defRPr sz="1300">
+                <a:solidFill>
+                  <a:srgbClr val="2C3E50"/>
+                </a:solidFill>
+              </a:defRPr>
+            </a:pPr>
+            <a:r>
+              <a:t>• Chosen from 6 backbones and 10 hybrids by grouped 5-fold CV: 66.5% vs 52.0% for EfficientNet-B0.</a:t>
+            </a:r>
+          </a:p>
+          <a:p>
+            <a:pPr>
+              <a:spcAft>
+                <a:spcPts val="600"/>
+              </a:spcAft>
+              <a:defRPr sz="1300">
+                <a:solidFill>
+                  <a:srgbClr val="2C3E50"/>
+                </a:solidFill>
+              </a:defRPr>
+            </a:pPr>
+            <a:r>
+              <a:t>• Rejects photos unlike any training leaf (out-of-distribution). 0.13 s per photo on CPU.</a:t>
             </a:r>
           </a:p>
         </p:txBody>
@@ -3943,7 +3944,7 @@
               </a:defRPr>
             </a:pPr>
             <a:r>
-              <a:t>• Threshold 0.65 triggers safe expert referral message.</a:t>
+              <a:t>• Threshold 0.61, chosen on training cross-validation (never the test set), triggers the expert referral.</a:t>
             </a:r>
           </a:p>
         </p:txBody>
@@ -4451,67 +4452,67 @@
               </a:defRPr>
             </a:pPr>
             <a:r>
-              <a:t>• Evaluated on 52 held-out real field photos from the IIT PlantDoc dataset.</a:t>
-            </a:r>
-          </a:p>
-          <a:p>
-            <a:pPr>
-              <a:spcAft>
-                <a:spcPts val="600"/>
-              </a:spcAft>
-              <a:defRPr sz="1300">
-                <a:solidFill>
-                  <a:srgbClr val="2C3E50"/>
-                </a:solidFill>
-              </a:defRPr>
-            </a:pPr>
-            <a:r>
-              <a:t>• Top-1 Accuracy: 61.54% | Top-3 Accuracy: 100% (EfficientNet-B0: 38.5% | 80.8%).</a:t>
-            </a:r>
-          </a:p>
-          <a:p>
-            <a:pPr>
-              <a:spcAft>
-                <a:spcPts val="600"/>
-              </a:spcAft>
-              <a:defRPr sz="1300">
-                <a:solidFill>
-                  <a:srgbClr val="2C3E50"/>
-                </a:solidFill>
-              </a:defRPr>
-            </a:pPr>
-            <a:r>
-              <a:t>• Quality Gate Pass Rate: 84.62% (filters out severe blur and extreme shadows).</a:t>
-            </a:r>
-          </a:p>
-          <a:p>
-            <a:pPr>
-              <a:spcAft>
-                <a:spcPts val="600"/>
-              </a:spcAft>
-              <a:defRPr sz="1300">
-                <a:solidFill>
-                  <a:srgbClr val="2C3E50"/>
-                </a:solidFill>
-              </a:defRPr>
-            </a:pPr>
-            <a:r>
-              <a:t>• Diagnostic Accuracy on TRUSTED photos jumps to 81.25% (peaks at 85.0%).</a:t>
-            </a:r>
-          </a:p>
-          <a:p>
-            <a:pPr>
-              <a:spcAft>
-                <a:spcPts val="600"/>
-              </a:spcAft>
-              <a:defRPr sz="1300">
-                <a:solidFill>
-                  <a:srgbClr val="2C3E50"/>
-                </a:solidFill>
-              </a:defRPr>
-            </a:pPr>
-            <a:r>
-              <a:t>• Strict adherence to Responsible AI: Honest metrics, zero lab-photo contamination.</a:t>
+              <a:t>• 45 held-out PlantDoc field photos, de-duplicated against training.</a:t>
+            </a:r>
+          </a:p>
+          <a:p>
+            <a:pPr>
+              <a:spcAft>
+                <a:spcPts val="600"/>
+              </a:spcAft>
+              <a:defRPr sz="1300">
+                <a:solidFill>
+                  <a:srgbClr val="2C3E50"/>
+                </a:solidFill>
+              </a:defRPr>
+            </a:pPr>
+            <a:r>
+              <a:t>• Top-1: 66.7% (95% CI 51-80%) | Top-3: 97.8% (fine-tuned EfficientNet-B0: 38.5% top-1).</a:t>
+            </a:r>
+          </a:p>
+          <a:p>
+            <a:pPr>
+              <a:spcAft>
+                <a:spcPts val="600"/>
+              </a:spcAft>
+              <a:defRPr sz="1300">
+                <a:solidFill>
+                  <a:srgbClr val="2C3E50"/>
+                </a:solidFill>
+              </a:defRPr>
+            </a:pPr>
+            <a:r>
+              <a:t>• Quality gate passes 84.4% of real test photos.</a:t>
+            </a:r>
+          </a:p>
+          <a:p>
+            <a:pPr>
+              <a:spcAft>
+                <a:spcPts val="600"/>
+              </a:spcAft>
+              <a:defRPr sz="1300">
+                <a:solidFill>
+                  <a:srgbClr val="2C3E50"/>
+                </a:solidFill>
+              </a:defRPr>
+            </a:pPr>
+            <a:r>
+              <a:t>• Answered photos (trusted): 42% of photos, 89.5% correct (17/19).</a:t>
+            </a:r>
+          </a:p>
+          <a:p>
+            <a:pPr>
+              <a:spcAft>
+                <a:spcPts val="600"/>
+              </a:spcAft>
+              <a:defRPr sz="1300">
+                <a:solidFill>
+                  <a:srgbClr val="2C3E50"/>
+                </a:solidFill>
+              </a:defRPr>
+            </a:pPr>
+            <a:r>
+              <a:t>• Per-class F1 0.59-0.80; most common error: healthy tomato read as bacterial spot.</a:t>
             </a:r>
           </a:p>
         </p:txBody>
@@ -4583,52 +4584,52 @@
               </a:defRPr>
             </a:pPr>
             <a:r>
-              <a:t>• Evaluates Selective Accuracy vs Coverage across Trust thresholds [0.35 to 0.85].</a:t>
-            </a:r>
-          </a:p>
-          <a:p>
-            <a:pPr>
-              <a:spcAft>
-                <a:spcPts val="600"/>
-              </a:spcAft>
-              <a:defRPr sz="1300">
-                <a:solidFill>
-                  <a:srgbClr val="2C3E50"/>
-                </a:solidFill>
-              </a:defRPr>
-            </a:pPr>
-            <a:r>
-              <a:t>• Key Finding: Filtering unconfident/poor images yields a +19.7 to +23.5 point precision boost.</a:t>
-            </a:r>
-          </a:p>
-          <a:p>
-            <a:pPr>
-              <a:spcAft>
-                <a:spcPts val="600"/>
-              </a:spcAft>
-              <a:defRPr sz="1300">
-                <a:solidFill>
-                  <a:srgbClr val="2C3E50"/>
-                </a:solidFill>
-              </a:defRPr>
-            </a:pPr>
-            <a:r>
-              <a:t>• Proves that our Mamdani Fuzzy Trust Engine successfully eliminates confident false diagnoses.</a:t>
-            </a:r>
-          </a:p>
-          <a:p>
-            <a:pPr>
-              <a:spcAft>
-                <a:spcPts val="600"/>
-              </a:spcAft>
-              <a:defRPr sz="1300">
-                <a:solidFill>
-                  <a:srgbClr val="2C3E50"/>
-                </a:solidFill>
-              </a:defRPr>
-            </a:pPr>
-            <a:r>
-              <a:t>• Protects Indian farmers from spending money on incorrect chemical fungicides.</a:t>
+              <a:t>• Accuracy on answered photos vs share of photos answered, across trust thresholds.</a:t>
+            </a:r>
+          </a:p>
+          <a:p>
+            <a:pPr>
+              <a:spcAft>
+                <a:spcPts val="600"/>
+              </a:spcAft>
+              <a:defRPr sz="1300">
+                <a:solidFill>
+                  <a:srgbClr val="2C3E50"/>
+                </a:solidFill>
+              </a:defRPr>
+            </a:pPr>
+            <a:r>
+              <a:t>• Answering everything: 66.7% correct. At our threshold: 89.5% correct on 42% of photos.</a:t>
+            </a:r>
+          </a:p>
+          <a:p>
+            <a:pPr>
+              <a:spcAft>
+                <a:spcPts val="600"/>
+              </a:spcAft>
+              <a:defRPr sz="1300">
+                <a:solidFill>
+                  <a:srgbClr val="2C3E50"/>
+                </a:solidFill>
+              </a:defRPr>
+            </a:pPr>
+            <a:r>
+              <a:t>• The trust engine sharply reduces confident wrong diagnoses; it does not remove them all.</a:t>
+            </a:r>
+          </a:p>
+          <a:p>
+            <a:pPr>
+              <a:spcAft>
+                <a:spcPts val="600"/>
+              </a:spcAft>
+              <a:defRPr sz="1300">
+                <a:solidFill>
+                  <a:srgbClr val="2C3E50"/>
+                </a:solidFill>
+              </a:defRPr>
+            </a:pPr>
+            <a:r>
+              <a:t>• Fewer wrong diagnoses means fewer wrong pesticide purchases.</a:t>
             </a:r>
           </a:p>
         </p:txBody>
@@ -4642,6 +4643,422 @@
 </file>
 
 <file path=ppt/slides/slide6.xml><?xml version="1.0" encoding="utf-8"?>
+<p:sld xmlns:a="http://schemas.openxmlformats.org/drawingml/2006/main" xmlns:p="http://schemas.openxmlformats.org/presentationml/2006/main" xmlns:r="http://schemas.openxmlformats.org/officeDocument/2006/relationships">
+  <p:cSld>
+    <p:spTree>
+      <p:nvGrpSpPr>
+        <p:cNvPr id="1" name=""/>
+        <p:cNvGrpSpPr/>
+        <p:nvPr/>
+      </p:nvGrpSpPr>
+      <p:grpSpPr/>
+      <p:sp>
+        <p:nvSpPr>
+          <p:cNvPr id="2" name="TextBox 1"/>
+          <p:cNvSpPr txBox="1"/>
+          <p:nvPr/>
+        </p:nvSpPr>
+        <p:spPr>
+          <a:xfrm>
+            <a:off x="731520" y="457200"/>
+            <a:ext cx="10698480" cy="1097280"/>
+          </a:xfrm>
+          <a:prstGeom prst="rect">
+            <a:avLst/>
+          </a:prstGeom>
+          <a:noFill/>
+        </p:spPr>
+        <p:txBody>
+          <a:bodyPr wrap="square">
+            <a:spAutoFit/>
+          </a:bodyPr>
+          <a:lstStyle/>
+          <a:p>
+            <a:pPr>
+              <a:defRPr sz="1100" b="1">
+                <a:solidFill>
+                  <a:srgbClr val="2ECC71"/>
+                </a:solidFill>
+              </a:defRPr>
+            </a:pPr>
+            <a:r>
+              <a:t>NEXAI HACK 2026 · TRACK 2 (SMART AGRICULTURE)</a:t>
+            </a:r>
+          </a:p>
+          <a:p>
+            <a:pPr>
+              <a:defRPr sz="2600" b="1">
+                <a:solidFill>
+                  <a:srgbClr val="1B4D3E"/>
+                </a:solidFill>
+              </a:defRPr>
+            </a:pPr>
+            <a:r>
+              <a:t>Data Integrity, Robustness &amp; Honest Limits</a:t>
+            </a:r>
+          </a:p>
+        </p:txBody>
+      </p:sp>
+      <p:sp>
+        <p:nvSpPr>
+          <p:cNvPr id="3" name="Rounded Rectangle 2"/>
+          <p:cNvSpPr/>
+          <p:nvPr/>
+        </p:nvSpPr>
+        <p:spPr>
+          <a:xfrm>
+            <a:off x="731520" y="1645920"/>
+            <a:ext cx="3383280" cy="4572000"/>
+          </a:xfrm>
+          <a:prstGeom prst="roundRect">
+            <a:avLst/>
+          </a:prstGeom>
+          <a:solidFill>
+            <a:srgbClr val="FFFFFF"/>
+          </a:solidFill>
+          <a:ln w="19050">
+            <a:solidFill>
+              <a:srgbClr val="DAE1E7"/>
+            </a:solidFill>
+          </a:ln>
+        </p:spPr>
+        <p:style>
+          <a:lnRef idx="1">
+            <a:schemeClr val="accent1"/>
+          </a:lnRef>
+          <a:fillRef idx="3">
+            <a:schemeClr val="accent1"/>
+          </a:fillRef>
+          <a:effectRef idx="2">
+            <a:schemeClr val="accent1"/>
+          </a:effectRef>
+          <a:fontRef idx="minor">
+            <a:schemeClr val="lt1"/>
+          </a:fontRef>
+        </p:style>
+        <p:txBody>
+          <a:bodyPr rtlCol="0" anchor="ctr" wrap="square"/>
+          <a:lstStyle/>
+          <a:p>
+            <a:pPr algn="ctr">
+              <a:spcAft>
+                <a:spcPts val="1000"/>
+              </a:spcAft>
+              <a:defRPr sz="1600" b="1">
+                <a:solidFill>
+                  <a:srgbClr val="1B4D3E"/>
+                </a:solidFill>
+              </a:defRPr>
+            </a:pPr>
+            <a:r>
+              <a:t>🧹 Leakage Removed</a:t>
+            </a:r>
+          </a:p>
+          <a:p>
+            <a:pPr>
+              <a:spcAft>
+                <a:spcPts val="600"/>
+              </a:spcAft>
+              <a:defRPr sz="1300">
+                <a:solidFill>
+                  <a:srgbClr val="2C3E50"/>
+                </a:solidFill>
+              </a:defRPr>
+            </a:pPr>
+            <a:r>
+              <a:t>• PlantDoc is internet-scraped: copies repeat.</a:t>
+            </a:r>
+          </a:p>
+          <a:p>
+            <a:pPr>
+              <a:spcAft>
+                <a:spcPts val="600"/>
+              </a:spcAft>
+              <a:defRPr sz="1300">
+                <a:solidFill>
+                  <a:srgbClr val="2C3E50"/>
+                </a:solidFill>
+              </a:defRPr>
+            </a:pPr>
+            <a:r>
+              <a:t>• 7 test photos also sat in training: removed from test.</a:t>
+            </a:r>
+          </a:p>
+          <a:p>
+            <a:pPr>
+              <a:spcAft>
+                <a:spcPts val="600"/>
+              </a:spcAft>
+              <a:defRPr sz="1300">
+                <a:solidFill>
+                  <a:srgbClr val="2C3E50"/>
+                </a:solidFill>
+              </a:defRPr>
+            </a:pPr>
+            <a:r>
+              <a:t>• 15 photos filed under two different diseases (31 images): removed from training.</a:t>
+            </a:r>
+          </a:p>
+          <a:p>
+            <a:pPr>
+              <a:spcAft>
+                <a:spcPts val="600"/>
+              </a:spcAft>
+              <a:defRPr sz="1300">
+                <a:solidFill>
+                  <a:srgbClr val="2C3E50"/>
+                </a:solidFill>
+              </a:defRPr>
+            </a:pPr>
+            <a:r>
+              <a:t>• Near-duplicates kept in the same cross-validation fold.</a:t>
+            </a:r>
+          </a:p>
+        </p:txBody>
+      </p:sp>
+      <p:sp>
+        <p:nvSpPr>
+          <p:cNvPr id="4" name="Rounded Rectangle 3"/>
+          <p:cNvSpPr/>
+          <p:nvPr/>
+        </p:nvSpPr>
+        <p:spPr>
+          <a:xfrm>
+            <a:off x="4389120" y="1645920"/>
+            <a:ext cx="3383280" cy="4572000"/>
+          </a:xfrm>
+          <a:prstGeom prst="roundRect">
+            <a:avLst/>
+          </a:prstGeom>
+          <a:solidFill>
+            <a:srgbClr val="FFFFFF"/>
+          </a:solidFill>
+          <a:ln w="19050">
+            <a:solidFill>
+              <a:srgbClr val="DAE1E7"/>
+            </a:solidFill>
+          </a:ln>
+        </p:spPr>
+        <p:style>
+          <a:lnRef idx="1">
+            <a:schemeClr val="accent1"/>
+          </a:lnRef>
+          <a:fillRef idx="3">
+            <a:schemeClr val="accent1"/>
+          </a:fillRef>
+          <a:effectRef idx="2">
+            <a:schemeClr val="accent1"/>
+          </a:effectRef>
+          <a:fontRef idx="minor">
+            <a:schemeClr val="lt1"/>
+          </a:fontRef>
+        </p:style>
+        <p:txBody>
+          <a:bodyPr rtlCol="0" anchor="ctr" wrap="square"/>
+          <a:lstStyle/>
+          <a:p>
+            <a:pPr algn="ctr">
+              <a:spcAft>
+                <a:spcPts val="1000"/>
+              </a:spcAft>
+              <a:defRPr sz="1600" b="1">
+                <a:solidFill>
+                  <a:srgbClr val="1B4D3E"/>
+                </a:solidFill>
+              </a:defRPr>
+            </a:pPr>
+            <a:r>
+              <a:t>📷 Quality Gate Stress Test</a:t>
+            </a:r>
+          </a:p>
+          <a:p>
+            <a:pPr>
+              <a:spcAft>
+                <a:spcPts val="600"/>
+              </a:spcAft>
+              <a:defRPr sz="1300">
+                <a:solidFill>
+                  <a:srgbClr val="2C3E50"/>
+                </a:solidFill>
+              </a:defRPr>
+            </a:pPr>
+            <a:r>
+              <a:t>• Clean test photos, deliberately degraded:</a:t>
+            </a:r>
+          </a:p>
+          <a:p>
+            <a:pPr>
+              <a:spcAft>
+                <a:spcPts val="600"/>
+              </a:spcAft>
+              <a:defRPr sz="1300">
+                <a:solidFill>
+                  <a:srgbClr val="2C3E50"/>
+                </a:solidFill>
+              </a:defRPr>
+            </a:pPr>
+            <a:r>
+              <a:t>• Defocus blur 97% rejected · motion blur 79%.</a:t>
+            </a:r>
+          </a:p>
+          <a:p>
+            <a:pPr>
+              <a:spcAft>
+                <a:spcPts val="600"/>
+              </a:spcAft>
+              <a:defRPr sz="1300">
+                <a:solidFill>
+                  <a:srgbClr val="2C3E50"/>
+                </a:solidFill>
+              </a:defRPr>
+            </a:pPr>
+            <a:r>
+              <a:t>• Too dark 100% · glare 97% · leaf too small 100%.</a:t>
+            </a:r>
+          </a:p>
+          <a:p>
+            <a:pPr>
+              <a:spcAft>
+                <a:spcPts val="600"/>
+              </a:spcAft>
+              <a:defRPr sz="1300">
+                <a:solidFill>
+                  <a:srgbClr val="2C3E50"/>
+                </a:solidFill>
+              </a:defRPr>
+            </a:pPr>
+            <a:r>
+              <a:t>• Each rejection comes with the matching retake tip.</a:t>
+            </a:r>
+          </a:p>
+        </p:txBody>
+      </p:sp>
+      <p:sp>
+        <p:nvSpPr>
+          <p:cNvPr id="5" name="Rounded Rectangle 4"/>
+          <p:cNvSpPr/>
+          <p:nvPr/>
+        </p:nvSpPr>
+        <p:spPr>
+          <a:xfrm>
+            <a:off x="8046720" y="1645920"/>
+            <a:ext cx="3383280" cy="4572000"/>
+          </a:xfrm>
+          <a:prstGeom prst="roundRect">
+            <a:avLst/>
+          </a:prstGeom>
+          <a:solidFill>
+            <a:srgbClr val="FFFFFF"/>
+          </a:solidFill>
+          <a:ln w="19050">
+            <a:solidFill>
+              <a:srgbClr val="DAE1E7"/>
+            </a:solidFill>
+          </a:ln>
+        </p:spPr>
+        <p:style>
+          <a:lnRef idx="1">
+            <a:schemeClr val="accent1"/>
+          </a:lnRef>
+          <a:fillRef idx="3">
+            <a:schemeClr val="accent1"/>
+          </a:fillRef>
+          <a:effectRef idx="2">
+            <a:schemeClr val="accent1"/>
+          </a:effectRef>
+          <a:fontRef idx="minor">
+            <a:schemeClr val="lt1"/>
+          </a:fontRef>
+        </p:style>
+        <p:txBody>
+          <a:bodyPr rtlCol="0" anchor="ctr" wrap="square"/>
+          <a:lstStyle/>
+          <a:p>
+            <a:pPr algn="ctr">
+              <a:spcAft>
+                <a:spcPts val="1000"/>
+              </a:spcAft>
+              <a:defRPr sz="1600" b="1">
+                <a:solidFill>
+                  <a:srgbClr val="1B4D3E"/>
+                </a:solidFill>
+              </a:defRPr>
+            </a:pPr>
+            <a:r>
+              <a:t>⚖️ Limitations</a:t>
+            </a:r>
+          </a:p>
+          <a:p>
+            <a:pPr>
+              <a:spcAft>
+                <a:spcPts val="600"/>
+              </a:spcAft>
+              <a:defRPr sz="1300">
+                <a:solidFill>
+                  <a:srgbClr val="2C3E50"/>
+                </a:solidFill>
+              </a:defRPr>
+            </a:pPr>
+            <a:r>
+              <a:t>• Small test set (45 photos): wide confidence intervals.</a:t>
+            </a:r>
+          </a:p>
+          <a:p>
+            <a:pPr>
+              <a:spcAft>
+                <a:spcPts val="600"/>
+              </a:spcAft>
+              <a:defRPr sz="1300">
+                <a:solidFill>
+                  <a:srgbClr val="2C3E50"/>
+                </a:solidFill>
+              </a:defRPr>
+            </a:pPr>
+            <a:r>
+              <a:t>• Internet photos, not farmer phone captures.</a:t>
+            </a:r>
+          </a:p>
+          <a:p>
+            <a:pPr>
+              <a:spcAft>
+                <a:spcPts val="600"/>
+              </a:spcAft>
+              <a:defRPr sz="1300">
+                <a:solidFill>
+                  <a:srgbClr val="2C3E50"/>
+                </a:solidFill>
+              </a:defRPr>
+            </a:pPr>
+            <a:r>
+              <a:t>• 2 crops, 6 classes; other crops rejected as unsupported.</a:t>
+            </a:r>
+          </a:p>
+          <a:p>
+            <a:pPr>
+              <a:spcAft>
+                <a:spcPts val="600"/>
+              </a:spcAft>
+              <a:defRPr sz="1300">
+                <a:solidFill>
+                  <a:srgbClr val="2C3E50"/>
+                </a:solidFill>
+              </a:defRPr>
+            </a:pPr>
+            <a:r>
+              <a:t>• Says 'not sure' for ~6 in 10 photos, by design.</a:t>
+            </a:r>
+          </a:p>
+        </p:txBody>
+      </p:sp>
+    </p:spTree>
+  </p:cSld>
+  <p:clrMapOvr>
+    <a:masterClrMapping/>
+  </p:clrMapOvr>
+</p:sld>
+</file>
+
+<file path=ppt/slides/slide7.xml><?xml version="1.0" encoding="utf-8"?>
 <p:sld xmlns:a="http://schemas.openxmlformats.org/drawingml/2006/main" xmlns:p="http://schemas.openxmlformats.org/presentationml/2006/main" xmlns:r="http://schemas.openxmlformats.org/officeDocument/2006/relationships">
   <p:cSld>
     <p:spTree>
@@ -4810,7 +5227,7 @@
               </a:defRPr>
             </a:pPr>
             <a:r>
-              <a:t>• Runs on standard mobile browsers with minimal latency (&lt;150ms inference).</a:t>
+              <a:t>• Runs on standard mobile browsers; about 0.13 s model inference per photo on CPU.</a:t>
             </a:r>
           </a:p>
         </p:txBody>
@@ -4927,7 +5344,7 @@
               </a:defRPr>
             </a:pPr>
             <a:r>
-              <a:t>• Open-source GitHub repository with complete hourly commit logs.</a:t>
+              <a:t>• Open-source GitHub repository with full commit history and DEV_LOG.</a:t>
             </a:r>
           </a:p>
         </p:txBody>
@@ -4940,7 +5357,7 @@
 </p:sld>
 </file>
 
-<file path=ppt/slides/slide7.xml><?xml version="1.0" encoding="utf-8"?>
+<file path=ppt/slides/slide8.xml><?xml version="1.0" encoding="utf-8"?>
 <p:sld xmlns:a="http://schemas.openxmlformats.org/drawingml/2006/main" xmlns:p="http://schemas.openxmlformats.org/presentationml/2006/main" xmlns:r="http://schemas.openxmlformats.org/officeDocument/2006/relationships">
   <p:cSld>
     <p:spTree>

</xml_diff>